<commit_message>
Add sorting and searching algorithms
- Implemented Bubble Sort algorithm in BubbleSort.java
- Added Binary Search algorithm for Integer arrays in BuscaBinaria.java
- Created a generic Binary Search algorithm in BuscaBinariaGenerica.java
- Developed Sequential Search algorithms for Integer and String arrays in BuscaSequencial.java
- Updated presentation slides for Bubble Sort
</commit_message>
<xml_diff>
--- a/Slides/03-Bubble-Sort.pptx
+++ b/Slides/03-Bubble-Sort.pptx
@@ -304,7 +304,7 @@
           <a:p>
             <a:fld id="{A061563A-35C7-49EE-9FEB-8EB53781E0B1}" type="datetimeFigureOut">
               <a:rPr lang="pt-BR" smtClean="0"/>
-              <a:t>07/02/2026</a:t>
+              <a:t>22/08/2026</a:t>
             </a:fld>
             <a:endParaRPr lang="pt-BR" dirty="0"/>
           </a:p>
@@ -472,7 +472,7 @@
           <a:p>
             <a:fld id="{A061563A-35C7-49EE-9FEB-8EB53781E0B1}" type="datetimeFigureOut">
               <a:rPr lang="pt-BR" smtClean="0"/>
-              <a:t>07/02/2026</a:t>
+              <a:t>22/08/2026</a:t>
             </a:fld>
             <a:endParaRPr lang="pt-BR" dirty="0"/>
           </a:p>
@@ -650,7 +650,7 @@
           <a:p>
             <a:fld id="{A061563A-35C7-49EE-9FEB-8EB53781E0B1}" type="datetimeFigureOut">
               <a:rPr lang="pt-BR" smtClean="0"/>
-              <a:t>07/02/2026</a:t>
+              <a:t>22/08/2026</a:t>
             </a:fld>
             <a:endParaRPr lang="pt-BR" dirty="0"/>
           </a:p>
@@ -818,7 +818,7 @@
           <a:p>
             <a:fld id="{A061563A-35C7-49EE-9FEB-8EB53781E0B1}" type="datetimeFigureOut">
               <a:rPr lang="pt-BR" smtClean="0"/>
-              <a:t>07/02/2026</a:t>
+              <a:t>22/08/2026</a:t>
             </a:fld>
             <a:endParaRPr lang="pt-BR" dirty="0"/>
           </a:p>
@@ -1063,7 +1063,7 @@
           <a:p>
             <a:fld id="{A061563A-35C7-49EE-9FEB-8EB53781E0B1}" type="datetimeFigureOut">
               <a:rPr lang="pt-BR" smtClean="0"/>
-              <a:t>07/02/2026</a:t>
+              <a:t>22/08/2026</a:t>
             </a:fld>
             <a:endParaRPr lang="pt-BR" dirty="0"/>
           </a:p>
@@ -1348,7 +1348,7 @@
           <a:p>
             <a:fld id="{A061563A-35C7-49EE-9FEB-8EB53781E0B1}" type="datetimeFigureOut">
               <a:rPr lang="pt-BR" smtClean="0"/>
-              <a:t>07/02/2026</a:t>
+              <a:t>22/08/2026</a:t>
             </a:fld>
             <a:endParaRPr lang="pt-BR" dirty="0"/>
           </a:p>
@@ -1767,7 +1767,7 @@
           <a:p>
             <a:fld id="{A061563A-35C7-49EE-9FEB-8EB53781E0B1}" type="datetimeFigureOut">
               <a:rPr lang="pt-BR" smtClean="0"/>
-              <a:t>07/02/2026</a:t>
+              <a:t>22/08/2026</a:t>
             </a:fld>
             <a:endParaRPr lang="pt-BR" dirty="0"/>
           </a:p>
@@ -1884,7 +1884,7 @@
           <a:p>
             <a:fld id="{A061563A-35C7-49EE-9FEB-8EB53781E0B1}" type="datetimeFigureOut">
               <a:rPr lang="pt-BR" smtClean="0"/>
-              <a:t>07/02/2026</a:t>
+              <a:t>22/08/2026</a:t>
             </a:fld>
             <a:endParaRPr lang="pt-BR" dirty="0"/>
           </a:p>
@@ -1979,7 +1979,7 @@
           <a:p>
             <a:fld id="{A061563A-35C7-49EE-9FEB-8EB53781E0B1}" type="datetimeFigureOut">
               <a:rPr lang="pt-BR" smtClean="0"/>
-              <a:t>07/02/2026</a:t>
+              <a:t>22/08/2026</a:t>
             </a:fld>
             <a:endParaRPr lang="pt-BR" dirty="0"/>
           </a:p>
@@ -2254,7 +2254,7 @@
           <a:p>
             <a:fld id="{A061563A-35C7-49EE-9FEB-8EB53781E0B1}" type="datetimeFigureOut">
               <a:rPr lang="pt-BR" smtClean="0"/>
-              <a:t>07/02/2026</a:t>
+              <a:t>22/08/2026</a:t>
             </a:fld>
             <a:endParaRPr lang="pt-BR" dirty="0"/>
           </a:p>
@@ -2506,7 +2506,7 @@
           <a:p>
             <a:fld id="{A061563A-35C7-49EE-9FEB-8EB53781E0B1}" type="datetimeFigureOut">
               <a:rPr lang="pt-BR" smtClean="0"/>
-              <a:t>07/02/2026</a:t>
+              <a:t>22/08/2026</a:t>
             </a:fld>
             <a:endParaRPr lang="pt-BR" dirty="0"/>
           </a:p>
@@ -2720,7 +2720,7 @@
           <a:p>
             <a:fld id="{A061563A-35C7-49EE-9FEB-8EB53781E0B1}" type="datetimeFigureOut">
               <a:rPr lang="pt-BR" smtClean="0"/>
-              <a:t>07/02/2026</a:t>
+              <a:t>22/08/2026</a:t>
             </a:fld>
             <a:endParaRPr lang="pt-BR" dirty="0"/>
           </a:p>
@@ -3436,7 +3436,7 @@
               <a:t>alexandre.</a:t>
             </a:r>
             <a:r>
-              <a:rPr lang="pt-BR" sz="2000" dirty="0">
+              <a:rPr lang="pt-BR" sz="2000">
                 <a:solidFill>
                   <a:srgbClr val="FFFF00"/>
                 </a:solidFill>
@@ -3444,20 +3444,20 @@
               <a:t>silva</a:t>
             </a:r>
             <a:r>
-              <a:rPr lang="pt-BR" sz="2000" dirty="0">
+              <a:rPr lang="pt-BR" sz="2000">
                 <a:solidFill>
                   <a:srgbClr val="00B050"/>
                 </a:solidFill>
               </a:rPr>
-              <a:t>251</a:t>
-            </a:r>
-            <a:r>
-              <a:rPr lang="pt-BR" sz="2000" dirty="0">
+              <a:t>09</a:t>
+            </a:r>
+            <a:r>
+              <a:rPr lang="pt-BR" sz="2000">
                 <a:solidFill>
                   <a:srgbClr val="7030A0"/>
                 </a:solidFill>
               </a:rPr>
-              <a:t>@fatec.</a:t>
+              <a:t>@cps.</a:t>
             </a:r>
             <a:r>
               <a:rPr lang="pt-BR" sz="2000" dirty="0">

</xml_diff>